<commit_message>
updated dashboard with proper formatting
</commit_message>
<xml_diff>
--- a/Group_PPT.pptx
+++ b/Group_PPT.pptx
@@ -422,7 +422,7 @@
           <a:p>
             <a:fld id="{9D8190EA-5EEC-4300-B6AE-D9734C6C648E}" type="datetimeFigureOut">
               <a:rPr lang="en-US" smtClean="0"/>
-              <a:t>2/17/2026</a:t>
+              <a:t>3/3/2026</a:t>
             </a:fld>
             <a:endParaRPr lang="en-US" dirty="0"/>
           </a:p>
@@ -599,7 +599,7 @@
           <a:p>
             <a:fld id="{7487ADD9-2083-264C-A652-8D52D02F7E72}" type="datetimeFigureOut">
               <a:rPr lang="en-US" smtClean="0"/>
-              <a:t>2/17/2026</a:t>
+              <a:t>3/3/2026</a:t>
             </a:fld>
             <a:endParaRPr lang="en-US" dirty="0"/>
           </a:p>
@@ -9358,10 +9358,10 @@
       </p:sp>
       <p:pic>
         <p:nvPicPr>
-          <p:cNvPr id="5" name="Picture 4">
+          <p:cNvPr id="4" name="Picture 3">
             <a:extLst>
               <a:ext uri="{FF2B5EF4-FFF2-40B4-BE49-F238E27FC236}">
-                <a16:creationId xmlns:a16="http://schemas.microsoft.com/office/drawing/2014/main" id="{670F8FE4-B39F-AE86-B9C0-9023340CDDE8}"/>
+                <a16:creationId xmlns:a16="http://schemas.microsoft.com/office/drawing/2014/main" id="{C2A253A2-D09C-2C02-0B16-4711642A64AE}"/>
               </a:ext>
             </a:extLst>
           </p:cNvPr>
@@ -9378,8 +9378,8 @@
         </p:blipFill>
         <p:spPr>
           <a:xfrm>
-            <a:off x="452283" y="1028080"/>
-            <a:ext cx="4463845" cy="2772696"/>
+            <a:off x="649387" y="1108773"/>
+            <a:ext cx="4539132" cy="2520000"/>
           </a:xfrm>
           <a:prstGeom prst="rect">
             <a:avLst/>
@@ -9388,10 +9388,10 @@
       </p:pic>
       <p:pic>
         <p:nvPicPr>
-          <p:cNvPr id="7" name="Picture 6">
+          <p:cNvPr id="8" name="Picture 7">
             <a:extLst>
               <a:ext uri="{FF2B5EF4-FFF2-40B4-BE49-F238E27FC236}">
-                <a16:creationId xmlns:a16="http://schemas.microsoft.com/office/drawing/2014/main" id="{B7FF5B1F-0156-2173-D7FE-54E83909391A}"/>
+                <a16:creationId xmlns:a16="http://schemas.microsoft.com/office/drawing/2014/main" id="{1D1D6568-86B6-8DE9-4EA6-C68866CAD027}"/>
               </a:ext>
             </a:extLst>
           </p:cNvPr>
@@ -9408,8 +9408,8 @@
         </p:blipFill>
         <p:spPr>
           <a:xfrm>
-            <a:off x="5776452" y="1002891"/>
-            <a:ext cx="4463845" cy="2772696"/>
+            <a:off x="6096000" y="1108773"/>
+            <a:ext cx="4556443" cy="2520000"/>
           </a:xfrm>
           <a:prstGeom prst="rect">
             <a:avLst/>
@@ -9418,10 +9418,10 @@
       </p:pic>
       <p:pic>
         <p:nvPicPr>
-          <p:cNvPr id="9" name="Picture 8">
+          <p:cNvPr id="11" name="Picture 10">
             <a:extLst>
               <a:ext uri="{FF2B5EF4-FFF2-40B4-BE49-F238E27FC236}">
-                <a16:creationId xmlns:a16="http://schemas.microsoft.com/office/drawing/2014/main" id="{C8AABA5E-A061-B8A1-67F8-F5F3710FFE50}"/>
+                <a16:creationId xmlns:a16="http://schemas.microsoft.com/office/drawing/2014/main" id="{A5E0C903-85F5-3229-BBED-C4750A437690}"/>
               </a:ext>
             </a:extLst>
           </p:cNvPr>
@@ -9438,8 +9438,8 @@
         </p:blipFill>
         <p:spPr>
           <a:xfrm>
-            <a:off x="3180735" y="3958093"/>
-            <a:ext cx="4827640" cy="2772696"/>
+            <a:off x="3352035" y="3901084"/>
+            <a:ext cx="4521869" cy="2520000"/>
           </a:xfrm>
           <a:prstGeom prst="rect">
             <a:avLst/>
@@ -9478,10 +9478,10 @@
       </p:grpSpPr>
       <p:pic>
         <p:nvPicPr>
-          <p:cNvPr id="5" name="Picture 4">
+          <p:cNvPr id="3" name="Picture 2">
             <a:extLst>
               <a:ext uri="{FF2B5EF4-FFF2-40B4-BE49-F238E27FC236}">
-                <a16:creationId xmlns:a16="http://schemas.microsoft.com/office/drawing/2014/main" id="{BE9BA804-6CBD-F49C-BE44-D9F9828FA2FE}"/>
+                <a16:creationId xmlns:a16="http://schemas.microsoft.com/office/drawing/2014/main" id="{38CA84D1-A566-0381-BE00-782798A2C715}"/>
               </a:ext>
             </a:extLst>
           </p:cNvPr>
@@ -9498,8 +9498,8 @@
         </p:blipFill>
         <p:spPr>
           <a:xfrm>
-            <a:off x="501445" y="835742"/>
-            <a:ext cx="4257367" cy="2920180"/>
+            <a:off x="599308" y="351995"/>
+            <a:ext cx="4501672" cy="2520000"/>
           </a:xfrm>
           <a:prstGeom prst="rect">
             <a:avLst/>
@@ -9508,10 +9508,10 @@
       </p:pic>
       <p:pic>
         <p:nvPicPr>
-          <p:cNvPr id="7" name="Picture 6">
+          <p:cNvPr id="6" name="Picture 5">
             <a:extLst>
               <a:ext uri="{FF2B5EF4-FFF2-40B4-BE49-F238E27FC236}">
-                <a16:creationId xmlns:a16="http://schemas.microsoft.com/office/drawing/2014/main" id="{F6530CBF-AFB9-4761-CCD2-84FEB6BC4DB6}"/>
+                <a16:creationId xmlns:a16="http://schemas.microsoft.com/office/drawing/2014/main" id="{60C255D6-0964-556A-DCEA-4BA65B53CCEF}"/>
               </a:ext>
             </a:extLst>
           </p:cNvPr>
@@ -9528,8 +9528,8 @@
         </p:blipFill>
         <p:spPr>
           <a:xfrm>
-            <a:off x="5083280" y="849261"/>
-            <a:ext cx="4699819" cy="2893141"/>
+            <a:off x="6409866" y="351995"/>
+            <a:ext cx="4550220" cy="2520000"/>
           </a:xfrm>
           <a:prstGeom prst="rect">
             <a:avLst/>
@@ -9538,10 +9538,10 @@
       </p:pic>
       <p:pic>
         <p:nvPicPr>
-          <p:cNvPr id="9" name="Picture 8">
+          <p:cNvPr id="10" name="Picture 9">
             <a:extLst>
               <a:ext uri="{FF2B5EF4-FFF2-40B4-BE49-F238E27FC236}">
-                <a16:creationId xmlns:a16="http://schemas.microsoft.com/office/drawing/2014/main" id="{00E1FD9A-CD0E-8C62-1F68-DA031FBBFD3F}"/>
+                <a16:creationId xmlns:a16="http://schemas.microsoft.com/office/drawing/2014/main" id="{169C9676-DA52-0407-8007-78041E184341}"/>
               </a:ext>
             </a:extLst>
           </p:cNvPr>
@@ -9558,8 +9558,8 @@
         </p:blipFill>
         <p:spPr>
           <a:xfrm>
-            <a:off x="427702" y="4087761"/>
-            <a:ext cx="4257367" cy="2743200"/>
+            <a:off x="599308" y="3527814"/>
+            <a:ext cx="4517275" cy="2520000"/>
           </a:xfrm>
           <a:prstGeom prst="rect">
             <a:avLst/>
@@ -9568,10 +9568,10 @@
       </p:pic>
       <p:pic>
         <p:nvPicPr>
-          <p:cNvPr id="11" name="Picture 10">
+          <p:cNvPr id="13" name="Picture 12">
             <a:extLst>
               <a:ext uri="{FF2B5EF4-FFF2-40B4-BE49-F238E27FC236}">
-                <a16:creationId xmlns:a16="http://schemas.microsoft.com/office/drawing/2014/main" id="{87BBD27F-642D-9A23-0B4A-AE67554EF0C8}"/>
+                <a16:creationId xmlns:a16="http://schemas.microsoft.com/office/drawing/2014/main" id="{38799189-58FB-6932-81D6-9A72FBE5E258}"/>
               </a:ext>
             </a:extLst>
           </p:cNvPr>
@@ -9588,8 +9588,8 @@
         </p:blipFill>
         <p:spPr>
           <a:xfrm>
-            <a:off x="4994789" y="4114800"/>
-            <a:ext cx="4699820" cy="2743200"/>
+            <a:off x="6370656" y="3527814"/>
+            <a:ext cx="4589430" cy="2520000"/>
           </a:xfrm>
           <a:prstGeom prst="rect">
             <a:avLst/>
@@ -10842,15 +10842,6 @@
 </file>
 
 <file path=customXml/item1.xml><?xml version="1.0" encoding="utf-8"?>
-<?mso-contentType ?>
-<FormTemplates xmlns="http://schemas.microsoft.com/sharepoint/v3/contenttype/forms">
-  <Display>DocumentLibraryForm</Display>
-  <Edit>DocumentLibraryForm</Edit>
-  <New>DocumentLibraryForm</New>
-</FormTemplates>
-</file>
-
-<file path=customXml/item2.xml><?xml version="1.0" encoding="utf-8"?>
 <ct:contentTypeSchema xmlns:ct="http://schemas.microsoft.com/office/2006/metadata/contentType" xmlns:ma="http://schemas.microsoft.com/office/2006/metadata/properties/metaAttributes" ct:_="" ma:_="" ma:contentTypeName="Document" ma:contentTypeID="0x01010079F111ED35F8CC479449609E8A0923A6" ma:contentTypeVersion="28" ma:contentTypeDescription="Create a new document." ma:contentTypeScope="" ma:versionID="60f5a4f2d2b0abadcf532d48ebf9cb71">
   <xsd:schema xmlns:xsd="http://www.w3.org/2001/XMLSchema" xmlns:xs="http://www.w3.org/2001/XMLSchema" xmlns:p="http://schemas.microsoft.com/office/2006/metadata/properties" xmlns:ns1="http://schemas.microsoft.com/sharepoint/v3" xmlns:ns2="71af3243-3dd4-4a8d-8c0d-dd76da1f02a5" xmlns:ns3="16c05727-aa75-4e4a-9b5f-8a80a1165891" xmlns:ns4="230e9df3-be65-4c73-a93b-d1236ebd677e" targetNamespace="http://schemas.microsoft.com/office/2006/metadata/properties" ma:root="true" ma:fieldsID="7dd78129e6a1811f84807ad11c651531" ns1:_="" ns2:_="" ns3:_="" ns4:_="">
     <xsd:import namespace="http://schemas.microsoft.com/sharepoint/v3"/>
@@ -11162,6 +11153,15 @@
 </ct:contentTypeSchema>
 </file>
 
+<file path=customXml/item2.xml><?xml version="1.0" encoding="utf-8"?>
+<?mso-contentType ?>
+<FormTemplates xmlns="http://schemas.microsoft.com/sharepoint/v3/contenttype/forms">
+  <Display>DocumentLibraryForm</Display>
+  <Edit>DocumentLibraryForm</Edit>
+  <New>DocumentLibraryForm</New>
+</FormTemplates>
+</file>
+
 <file path=customXml/item3.xml><?xml version="1.0" encoding="utf-8"?>
 <p:properties xmlns:p="http://schemas.microsoft.com/office/2006/metadata/properties" xmlns:xsi="http://www.w3.org/2001/XMLSchema-instance" xmlns:pc="http://schemas.microsoft.com/office/infopath/2007/PartnerControls">
   <documentManagement>
@@ -11183,14 +11183,6 @@
 </file>
 
 <file path=customXml/itemProps1.xml><?xml version="1.0" encoding="utf-8"?>
-<ds:datastoreItem xmlns:ds="http://schemas.openxmlformats.org/officeDocument/2006/customXml" ds:itemID="{45A8381C-73EB-48EA-B45F-7B7C8C7DF409}">
-  <ds:schemaRefs>
-    <ds:schemaRef ds:uri="http://schemas.microsoft.com/sharepoint/v3/contenttype/forms"/>
-  </ds:schemaRefs>
-</ds:datastoreItem>
-</file>
-
-<file path=customXml/itemProps2.xml><?xml version="1.0" encoding="utf-8"?>
 <ds:datastoreItem xmlns:ds="http://schemas.openxmlformats.org/officeDocument/2006/customXml" ds:itemID="{5AA6A711-2C3F-4EC0-B88B-62D740851176}">
   <ds:schemaRefs>
     <ds:schemaRef ds:uri="http://schemas.microsoft.com/office/2006/metadata/contentType"/>
@@ -11211,6 +11203,14 @@
 </ds:datastoreItem>
 </file>
 
+<file path=customXml/itemProps2.xml><?xml version="1.0" encoding="utf-8"?>
+<ds:datastoreItem xmlns:ds="http://schemas.openxmlformats.org/officeDocument/2006/customXml" ds:itemID="{45A8381C-73EB-48EA-B45F-7B7C8C7DF409}">
+  <ds:schemaRefs>
+    <ds:schemaRef ds:uri="http://schemas.microsoft.com/sharepoint/v3/contenttype/forms"/>
+  </ds:schemaRefs>
+</ds:datastoreItem>
+</file>
+
 <file path=customXml/itemProps3.xml><?xml version="1.0" encoding="utf-8"?>
 <ds:datastoreItem xmlns:ds="http://schemas.openxmlformats.org/officeDocument/2006/customXml" ds:itemID="{61E98C35-9ECE-4425-BCBA-00E118C705CE}">
   <ds:schemaRefs>

</xml_diff>